<commit_message>
Add team name and repository to the title slide and README
</commit_message>
<xml_diff>
--- a/slides/olist_late_delivery_presentation.pptx
+++ b/slides/olist_late_delivery_presentation.pptx
@@ -7353,6 +7353,22 @@
               </a:spcAft>
             </a:pPr>
             <a:r>
+              <a:rPr sz="2000" b="1" i="0">
+                <a:solidFill>
+                  <a:srgbClr val="3669E8"/>
+                </a:solidFill>
+                <a:latin typeface="Calibri"/>
+              </a:rPr>
+              <a:t>Group 9</a:t>
+            </a:r>
+          </a:p>
+          <a:p>
+            <a:pPr algn="l">
+              <a:spcAft>
+                <a:spcPts val="600"/>
+              </a:spcAft>
+            </a:pPr>
+            <a:r>
               <a:rPr sz="1800" b="0" i="0">
                 <a:solidFill>
                   <a:srgbClr val="111111"/>
@@ -7360,6 +7376,22 @@
                 <a:latin typeface="Calibri"/>
               </a:rPr>
               <a:t>Fidan Shiraliyeva · Hasan Malik · Jay Malhotra · Jingyu Wu · Mia Scalabrin · Peace Isaac · Tasnim Hassan</a:t>
+            </a:r>
+          </a:p>
+          <a:p>
+            <a:pPr algn="l">
+              <a:spcAft>
+                <a:spcPts val="600"/>
+              </a:spcAft>
+            </a:pPr>
+            <a:r>
+              <a:rPr sz="1800" b="0" i="0">
+                <a:solidFill>
+                  <a:srgbClr val="3669E8"/>
+                </a:solidFill>
+                <a:latin typeface="Calibri"/>
+              </a:rPr>
+              <a:t>GitHub repository: olist-late-delivery (github.com/JustJay7/olist-late-delivery)</a:t>
             </a:r>
           </a:p>
         </p:txBody>

</xml_diff>

<commit_message>
Fix audit issues: rebuildable data, trimmed notebooks, corrected README and slides
</commit_message>
<xml_diff>
--- a/slides/olist_late_delivery_presentation.pptx
+++ b/slides/olist_late_delivery_presentation.pptx
@@ -3149,7 +3149,7 @@
           <a:lstStyle/>
           <a:p>
             <a:r>
-              <a:t>[0:50] On the test set, the strongest drivers are the promised window, distance, customer state, freight and whether the order ships within one state. A promise one standard deviation longer roughly halves the odds of being late. Price, weight, category and purchase time barely matter. Jingyu's error analysis on the last validation fold, before tuning, shows what the model misses: late orders that look ordinary, shorter and more often within one state. All three shortlisted models miss the same two-thirds, so the limit is the data, not the algorithm. A person would have needed the seller's hand-off to the carrier, carrier backlogs, strikes or holidays. (README 4.3, 5.4)</a:t>
+              <a:t>[0:50] On the test set, the strongest drivers are the promised window, distance, customer state, freight and whether the order ships within one state. A promise one standard deviation longer roughly halves the odds of being late. Price, weight, category and purchase time barely matter. Jingyu's error analysis on the last validation fold, before tuning, shows what the model misses: late orders that look ordinary, shorter and more often within one state. All three shortlisted models miss the same two-thirds. Part of that is the budget: on this fold, even a perfect model reviewing 10% of orders would miss 47% of the late ones. The rest points to the data, not the algorithm. A person would have needed the seller's hand-off to the carrier, carrier backlogs, strikes or holidays. (README 4.3, 5.4)</a:t>
             </a:r>
           </a:p>
           <a:p>
@@ -3724,7 +3724,7 @@
           <a:lstStyle/>
           <a:p>
             <a:r>
-              <a:t>Backup: tuning and ensemble comparison (README 5.1, 5.2; ensemble numbers from reports/figures/outputs/tasnim_5_2_ensemble_comparison.csv).</a:t>
+              <a:t>Backup: tuning and ensemble comparison (README 5.1, 5.2; ensemble numbers from reports/outputs/5_2_ensemble_comparison.csv).</a:t>
             </a:r>
           </a:p>
         </p:txBody>
@@ -3869,7 +3869,7 @@
           <a:lstStyle/>
           <a:p>
             <a:r>
-              <a:t>Backup: monthly test results (reports/figures/outputs/tasnim_5_3_monthly.csv) and calibration (README 5.4).</a:t>
+              <a:t>Backup: monthly test results (reports/outputs/5_3_monthly.csv) and calibration (README 5.4).</a:t>
             </a:r>
           </a:p>
         </p:txBody>
@@ -9405,7 +9405,7 @@
                 </a:solidFill>
                 <a:latin typeface="Calibri"/>
               </a:rPr>
-              <a:t>late orders that look ordinary, shorter than the ones it catches (727 vs 1,011 km) and more often in-state. All 3 shortlisted models miss the same 66%.</a:t>
+              <a:t>late orders that look ordinary, shorter than the ones it catches (727 vs 1,011 km) and more often in-state. All 3 models miss 66%, but at a 10% budget even a perfect model misses 47%.</a:t>
             </a:r>
           </a:p>
         </p:txBody>
@@ -12690,7 +12690,7 @@
                 </a:solidFill>
                 <a:latin typeface="Arial Black"/>
               </a:rPr>
-              <a:t>you ·</a:t>
+              <a:t>you</a:t>
             </a:r>
             <a:endParaRPr sz="4400" b="0" i="0" dirty="0">
               <a:solidFill>

</xml_diff>

<commit_message>
Assign presenters and finalise speaker notes
</commit_message>
<xml_diff>
--- a/slides/olist_late_delivery_presentation.pptx
+++ b/slides/olist_late_delivery_presentation.pptx
@@ -199,7 +199,7 @@
             </c:spPr>
             <c:extLst>
               <c:ext xmlns:c16="http://schemas.microsoft.com/office/drawing/2014/chart" uri="{C3380CC4-5D6E-409C-BE32-E72D297353CC}">
-                <c16:uniqueId val="{00000001-5CC0-DE43-8886-91F5D1F099D5}"/>
+                <c16:uniqueId val="{00000001-107D-5A4E-BA22-22882B08C341}"/>
               </c:ext>
             </c:extLst>
           </c:dPt>
@@ -283,7 +283,7 @@
               </c14:invertSolidFillFmt>
             </c:ext>
             <c:ext xmlns:c16="http://schemas.microsoft.com/office/drawing/2014/chart" uri="{C3380CC4-5D6E-409C-BE32-E72D297353CC}">
-              <c16:uniqueId val="{00000002-5CC0-DE43-8886-91F5D1F099D5}"/>
+              <c16:uniqueId val="{00000002-107D-5A4E-BA22-22882B08C341}"/>
             </c:ext>
           </c:extLst>
         </c:ser>
@@ -456,7 +456,7 @@
                   <c15:showDataLabelsRange val="0"/>
                 </c:ext>
                 <c:ext xmlns:c16="http://schemas.microsoft.com/office/drawing/2014/chart" uri="{C3380CC4-5D6E-409C-BE32-E72D297353CC}">
-                  <c16:uniqueId val="{00000000-4E72-5D47-A42B-EFDB9964780F}"/>
+                  <c16:uniqueId val="{00000000-8655-3949-9436-AE6B405FF965}"/>
                 </c:ext>
               </c:extLst>
             </c:dLbl>
@@ -490,7 +490,7 @@
                   <c15:showDataLabelsRange val="0"/>
                 </c:ext>
                 <c:ext xmlns:c16="http://schemas.microsoft.com/office/drawing/2014/chart" uri="{C3380CC4-5D6E-409C-BE32-E72D297353CC}">
-                  <c16:uniqueId val="{00000001-4E72-5D47-A42B-EFDB9964780F}"/>
+                  <c16:uniqueId val="{00000001-8655-3949-9436-AE6B405FF965}"/>
                 </c:ext>
               </c:extLst>
             </c:dLbl>
@@ -524,7 +524,7 @@
                   <c15:showDataLabelsRange val="0"/>
                 </c:ext>
                 <c:ext xmlns:c16="http://schemas.microsoft.com/office/drawing/2014/chart" uri="{C3380CC4-5D6E-409C-BE32-E72D297353CC}">
-                  <c16:uniqueId val="{00000002-4E72-5D47-A42B-EFDB9964780F}"/>
+                  <c16:uniqueId val="{00000002-8655-3949-9436-AE6B405FF965}"/>
                 </c:ext>
               </c:extLst>
             </c:dLbl>
@@ -669,7 +669,7 @@
           <c:smooth val="0"/>
           <c:extLst>
             <c:ext xmlns:c16="http://schemas.microsoft.com/office/drawing/2014/chart" uri="{C3380CC4-5D6E-409C-BE32-E72D297353CC}">
-              <c16:uniqueId val="{00000003-4E72-5D47-A42B-EFDB9964780F}"/>
+              <c16:uniqueId val="{00000003-8655-3949-9436-AE6B405FF965}"/>
             </c:ext>
           </c:extLst>
         </c:ser>
@@ -797,7 +797,7 @@
           <c:smooth val="0"/>
           <c:extLst>
             <c:ext xmlns:c16="http://schemas.microsoft.com/office/drawing/2014/chart" uri="{C3380CC4-5D6E-409C-BE32-E72D297353CC}">
-              <c16:uniqueId val="{00000004-4E72-5D47-A42B-EFDB9964780F}"/>
+              <c16:uniqueId val="{00000004-8655-3949-9436-AE6B405FF965}"/>
             </c:ext>
           </c:extLst>
         </c:ser>
@@ -969,7 +969,7 @@
             </c:spPr>
             <c:extLst>
               <c:ext xmlns:c16="http://schemas.microsoft.com/office/drawing/2014/chart" uri="{C3380CC4-5D6E-409C-BE32-E72D297353CC}">
-                <c16:uniqueId val="{00000001-345B-4C4D-B699-4A4CC25A66F5}"/>
+                <c16:uniqueId val="{00000001-45B8-6741-8847-E1A0CD22DE70}"/>
               </c:ext>
             </c:extLst>
           </c:dPt>
@@ -984,7 +984,7 @@
             </c:spPr>
             <c:extLst>
               <c:ext xmlns:c16="http://schemas.microsoft.com/office/drawing/2014/chart" uri="{C3380CC4-5D6E-409C-BE32-E72D297353CC}">
-                <c16:uniqueId val="{00000003-345B-4C4D-B699-4A4CC25A66F5}"/>
+                <c16:uniqueId val="{00000003-45B8-6741-8847-E1A0CD22DE70}"/>
               </c:ext>
             </c:extLst>
           </c:dPt>
@@ -999,7 +999,7 @@
             </c:spPr>
             <c:extLst>
               <c:ext xmlns:c16="http://schemas.microsoft.com/office/drawing/2014/chart" uri="{C3380CC4-5D6E-409C-BE32-E72D297353CC}">
-                <c16:uniqueId val="{00000005-345B-4C4D-B699-4A4CC25A66F5}"/>
+                <c16:uniqueId val="{00000005-45B8-6741-8847-E1A0CD22DE70}"/>
               </c:ext>
             </c:extLst>
           </c:dPt>
@@ -1014,7 +1014,7 @@
             </c:spPr>
             <c:extLst>
               <c:ext xmlns:c16="http://schemas.microsoft.com/office/drawing/2014/chart" uri="{C3380CC4-5D6E-409C-BE32-E72D297353CC}">
-                <c16:uniqueId val="{00000007-345B-4C4D-B699-4A4CC25A66F5}"/>
+                <c16:uniqueId val="{00000007-45B8-6741-8847-E1A0CD22DE70}"/>
               </c:ext>
             </c:extLst>
           </c:dPt>
@@ -1029,7 +1029,7 @@
             </c:spPr>
             <c:extLst>
               <c:ext xmlns:c16="http://schemas.microsoft.com/office/drawing/2014/chart" uri="{C3380CC4-5D6E-409C-BE32-E72D297353CC}">
-                <c16:uniqueId val="{00000009-345B-4C4D-B699-4A4CC25A66F5}"/>
+                <c16:uniqueId val="{00000009-45B8-6741-8847-E1A0CD22DE70}"/>
               </c:ext>
             </c:extLst>
           </c:dPt>
@@ -1044,7 +1044,7 @@
             </c:spPr>
             <c:extLst>
               <c:ext xmlns:c16="http://schemas.microsoft.com/office/drawing/2014/chart" uri="{C3380CC4-5D6E-409C-BE32-E72D297353CC}">
-                <c16:uniqueId val="{0000000B-345B-4C4D-B699-4A4CC25A66F5}"/>
+                <c16:uniqueId val="{0000000B-45B8-6741-8847-E1A0CD22DE70}"/>
               </c:ext>
             </c:extLst>
           </c:dPt>
@@ -1059,7 +1059,7 @@
             </c:spPr>
             <c:extLst>
               <c:ext xmlns:c16="http://schemas.microsoft.com/office/drawing/2014/chart" uri="{C3380CC4-5D6E-409C-BE32-E72D297353CC}">
-                <c16:uniqueId val="{0000000D-345B-4C4D-B699-4A4CC25A66F5}"/>
+                <c16:uniqueId val="{0000000D-45B8-6741-8847-E1A0CD22DE70}"/>
               </c:ext>
             </c:extLst>
           </c:dPt>
@@ -1074,7 +1074,7 @@
             </c:spPr>
             <c:extLst>
               <c:ext xmlns:c16="http://schemas.microsoft.com/office/drawing/2014/chart" uri="{C3380CC4-5D6E-409C-BE32-E72D297353CC}">
-                <c16:uniqueId val="{0000000F-345B-4C4D-B699-4A4CC25A66F5}"/>
+                <c16:uniqueId val="{0000000F-45B8-6741-8847-E1A0CD22DE70}"/>
               </c:ext>
             </c:extLst>
           </c:dPt>
@@ -1089,7 +1089,7 @@
             </c:spPr>
             <c:extLst>
               <c:ext xmlns:c16="http://schemas.microsoft.com/office/drawing/2014/chart" uri="{C3380CC4-5D6E-409C-BE32-E72D297353CC}">
-                <c16:uniqueId val="{00000011-345B-4C4D-B699-4A4CC25A66F5}"/>
+                <c16:uniqueId val="{00000011-45B8-6741-8847-E1A0CD22DE70}"/>
               </c:ext>
             </c:extLst>
           </c:dPt>
@@ -1102,7 +1102,7 @@
                   <a:lstStyle/>
                   <a:p>
                     <a:r>
-                      <a:rPr sz="1600" b="1">
+                      <a:rPr lang="en-US" sz="1600" b="1">
                         <a:solidFill>
                           <a:srgbClr val="111111"/>
                         </a:solidFill>
@@ -1124,7 +1124,7 @@
                   <c15:showDataLabelsRange val="0"/>
                 </c:ext>
                 <c:ext xmlns:c16="http://schemas.microsoft.com/office/drawing/2014/chart" uri="{C3380CC4-5D6E-409C-BE32-E72D297353CC}">
-                  <c16:uniqueId val="{00000001-345B-4C4D-B699-4A4CC25A66F5}"/>
+                  <c16:uniqueId val="{00000001-45B8-6741-8847-E1A0CD22DE70}"/>
                 </c:ext>
               </c:extLst>
             </c:dLbl>
@@ -1136,7 +1136,7 @@
                   <a:lstStyle/>
                   <a:p>
                     <a:r>
-                      <a:rPr sz="1600" b="1">
+                      <a:rPr lang="en-US" sz="1600" b="1">
                         <a:solidFill>
                           <a:srgbClr val="111111"/>
                         </a:solidFill>
@@ -1158,7 +1158,7 @@
                   <c15:showDataLabelsRange val="0"/>
                 </c:ext>
                 <c:ext xmlns:c16="http://schemas.microsoft.com/office/drawing/2014/chart" uri="{C3380CC4-5D6E-409C-BE32-E72D297353CC}">
-                  <c16:uniqueId val="{00000003-345B-4C4D-B699-4A4CC25A66F5}"/>
+                  <c16:uniqueId val="{00000003-45B8-6741-8847-E1A0CD22DE70}"/>
                 </c:ext>
               </c:extLst>
             </c:dLbl>
@@ -1170,7 +1170,7 @@
                   <a:lstStyle/>
                   <a:p>
                     <a:r>
-                      <a:rPr sz="1600" b="1">
+                      <a:rPr lang="en-US" sz="1600" b="1">
                         <a:solidFill>
                           <a:srgbClr val="111111"/>
                         </a:solidFill>
@@ -1192,7 +1192,7 @@
                   <c15:showDataLabelsRange val="0"/>
                 </c:ext>
                 <c:ext xmlns:c16="http://schemas.microsoft.com/office/drawing/2014/chart" uri="{C3380CC4-5D6E-409C-BE32-E72D297353CC}">
-                  <c16:uniqueId val="{00000005-345B-4C4D-B699-4A4CC25A66F5}"/>
+                  <c16:uniqueId val="{00000005-45B8-6741-8847-E1A0CD22DE70}"/>
                 </c:ext>
               </c:extLst>
             </c:dLbl>
@@ -1204,7 +1204,7 @@
                   <a:lstStyle/>
                   <a:p>
                     <a:r>
-                      <a:rPr sz="1600" b="1">
+                      <a:rPr lang="en-US" sz="1600" b="1">
                         <a:solidFill>
                           <a:srgbClr val="111111"/>
                         </a:solidFill>
@@ -1226,7 +1226,7 @@
                   <c15:showDataLabelsRange val="0"/>
                 </c:ext>
                 <c:ext xmlns:c16="http://schemas.microsoft.com/office/drawing/2014/chart" uri="{C3380CC4-5D6E-409C-BE32-E72D297353CC}">
-                  <c16:uniqueId val="{00000007-345B-4C4D-B699-4A4CC25A66F5}"/>
+                  <c16:uniqueId val="{00000007-45B8-6741-8847-E1A0CD22DE70}"/>
                 </c:ext>
               </c:extLst>
             </c:dLbl>
@@ -1238,7 +1238,7 @@
                   <a:lstStyle/>
                   <a:p>
                     <a:r>
-                      <a:rPr sz="1600" b="1">
+                      <a:rPr lang="en-US" sz="1600" b="1">
                         <a:solidFill>
                           <a:srgbClr val="111111"/>
                         </a:solidFill>
@@ -1260,7 +1260,7 @@
                   <c15:showDataLabelsRange val="0"/>
                 </c:ext>
                 <c:ext xmlns:c16="http://schemas.microsoft.com/office/drawing/2014/chart" uri="{C3380CC4-5D6E-409C-BE32-E72D297353CC}">
-                  <c16:uniqueId val="{00000009-345B-4C4D-B699-4A4CC25A66F5}"/>
+                  <c16:uniqueId val="{00000009-45B8-6741-8847-E1A0CD22DE70}"/>
                 </c:ext>
               </c:extLst>
             </c:dLbl>
@@ -1272,7 +1272,7 @@
                   <a:lstStyle/>
                   <a:p>
                     <a:r>
-                      <a:rPr sz="1600" b="1">
+                      <a:rPr lang="en-US" sz="1600" b="1">
                         <a:solidFill>
                           <a:srgbClr val="111111"/>
                         </a:solidFill>
@@ -1294,7 +1294,7 @@
                   <c15:showDataLabelsRange val="0"/>
                 </c:ext>
                 <c:ext xmlns:c16="http://schemas.microsoft.com/office/drawing/2014/chart" uri="{C3380CC4-5D6E-409C-BE32-E72D297353CC}">
-                  <c16:uniqueId val="{0000000B-345B-4C4D-B699-4A4CC25A66F5}"/>
+                  <c16:uniqueId val="{0000000B-45B8-6741-8847-E1A0CD22DE70}"/>
                 </c:ext>
               </c:extLst>
             </c:dLbl>
@@ -1306,7 +1306,7 @@
                   <a:lstStyle/>
                   <a:p>
                     <a:r>
-                      <a:rPr sz="1600" b="1">
+                      <a:rPr lang="en-US" sz="1600" b="1">
                         <a:solidFill>
                           <a:srgbClr val="111111"/>
                         </a:solidFill>
@@ -1328,7 +1328,7 @@
                   <c15:showDataLabelsRange val="0"/>
                 </c:ext>
                 <c:ext xmlns:c16="http://schemas.microsoft.com/office/drawing/2014/chart" uri="{C3380CC4-5D6E-409C-BE32-E72D297353CC}">
-                  <c16:uniqueId val="{0000000D-345B-4C4D-B699-4A4CC25A66F5}"/>
+                  <c16:uniqueId val="{0000000D-45B8-6741-8847-E1A0CD22DE70}"/>
                 </c:ext>
               </c:extLst>
             </c:dLbl>
@@ -1340,7 +1340,7 @@
                   <a:lstStyle/>
                   <a:p>
                     <a:r>
-                      <a:rPr sz="1600" b="1">
+                      <a:rPr lang="en-US" sz="1600" b="1">
                         <a:solidFill>
                           <a:srgbClr val="111111"/>
                         </a:solidFill>
@@ -1362,7 +1362,7 @@
                   <c15:showDataLabelsRange val="0"/>
                 </c:ext>
                 <c:ext xmlns:c16="http://schemas.microsoft.com/office/drawing/2014/chart" uri="{C3380CC4-5D6E-409C-BE32-E72D297353CC}">
-                  <c16:uniqueId val="{0000000F-345B-4C4D-B699-4A4CC25A66F5}"/>
+                  <c16:uniqueId val="{0000000F-45B8-6741-8847-E1A0CD22DE70}"/>
                 </c:ext>
               </c:extLst>
             </c:dLbl>
@@ -1374,7 +1374,7 @@
                   <a:lstStyle/>
                   <a:p>
                     <a:r>
-                      <a:rPr sz="1600" b="1">
+                      <a:rPr lang="en-US" sz="1600" b="1">
                         <a:solidFill>
                           <a:srgbClr val="111111"/>
                         </a:solidFill>
@@ -1396,7 +1396,7 @@
                   <c15:showDataLabelsRange val="0"/>
                 </c:ext>
                 <c:ext xmlns:c16="http://schemas.microsoft.com/office/drawing/2014/chart" uri="{C3380CC4-5D6E-409C-BE32-E72D297353CC}">
-                  <c16:uniqueId val="{00000011-345B-4C4D-B699-4A4CC25A66F5}"/>
+                  <c16:uniqueId val="{00000011-45B8-6741-8847-E1A0CD22DE70}"/>
                 </c:ext>
               </c:extLst>
             </c:dLbl>
@@ -1504,7 +1504,7 @@
               </c14:invertSolidFillFmt>
             </c:ext>
             <c:ext xmlns:c16="http://schemas.microsoft.com/office/drawing/2014/chart" uri="{C3380CC4-5D6E-409C-BE32-E72D297353CC}">
-              <c16:uniqueId val="{00000012-345B-4C4D-B699-4A4CC25A66F5}"/>
+              <c16:uniqueId val="{00000012-45B8-6741-8847-E1A0CD22DE70}"/>
             </c:ext>
           </c:extLst>
         </c:ser>
@@ -1646,7 +1646,7 @@
             </c:spPr>
             <c:extLst>
               <c:ext xmlns:c16="http://schemas.microsoft.com/office/drawing/2014/chart" uri="{C3380CC4-5D6E-409C-BE32-E72D297353CC}">
-                <c16:uniqueId val="{00000001-C6DF-9047-9AA5-81BE378A2FA5}"/>
+                <c16:uniqueId val="{00000001-08BF-DE4C-98C3-A0D361776B3F}"/>
               </c:ext>
             </c:extLst>
           </c:dPt>
@@ -1661,7 +1661,7 @@
             </c:spPr>
             <c:extLst>
               <c:ext xmlns:c16="http://schemas.microsoft.com/office/drawing/2014/chart" uri="{C3380CC4-5D6E-409C-BE32-E72D297353CC}">
-                <c16:uniqueId val="{00000003-C6DF-9047-9AA5-81BE378A2FA5}"/>
+                <c16:uniqueId val="{00000003-08BF-DE4C-98C3-A0D361776B3F}"/>
               </c:ext>
             </c:extLst>
           </c:dPt>
@@ -1676,7 +1676,7 @@
             </c:spPr>
             <c:extLst>
               <c:ext xmlns:c16="http://schemas.microsoft.com/office/drawing/2014/chart" uri="{C3380CC4-5D6E-409C-BE32-E72D297353CC}">
-                <c16:uniqueId val="{00000005-C6DF-9047-9AA5-81BE378A2FA5}"/>
+                <c16:uniqueId val="{00000005-08BF-DE4C-98C3-A0D361776B3F}"/>
               </c:ext>
             </c:extLst>
           </c:dPt>
@@ -1691,7 +1691,7 @@
             </c:spPr>
             <c:extLst>
               <c:ext xmlns:c16="http://schemas.microsoft.com/office/drawing/2014/chart" uri="{C3380CC4-5D6E-409C-BE32-E72D297353CC}">
-                <c16:uniqueId val="{00000007-C6DF-9047-9AA5-81BE378A2FA5}"/>
+                <c16:uniqueId val="{00000007-08BF-DE4C-98C3-A0D361776B3F}"/>
               </c:ext>
             </c:extLst>
           </c:dPt>
@@ -1706,7 +1706,7 @@
             </c:spPr>
             <c:extLst>
               <c:ext xmlns:c16="http://schemas.microsoft.com/office/drawing/2014/chart" uri="{C3380CC4-5D6E-409C-BE32-E72D297353CC}">
-                <c16:uniqueId val="{00000009-C6DF-9047-9AA5-81BE378A2FA5}"/>
+                <c16:uniqueId val="{00000009-08BF-DE4C-98C3-A0D361776B3F}"/>
               </c:ext>
             </c:extLst>
           </c:dPt>
@@ -1719,7 +1719,7 @@
                   <a:lstStyle/>
                   <a:p>
                     <a:r>
-                      <a:rPr sz="1700" b="1">
+                      <a:rPr lang="en-US" sz="1700" b="1">
                         <a:solidFill>
                           <a:srgbClr val="111111"/>
                         </a:solidFill>
@@ -1741,7 +1741,7 @@
                   <c15:showDataLabelsRange val="0"/>
                 </c:ext>
                 <c:ext xmlns:c16="http://schemas.microsoft.com/office/drawing/2014/chart" uri="{C3380CC4-5D6E-409C-BE32-E72D297353CC}">
-                  <c16:uniqueId val="{00000001-C6DF-9047-9AA5-81BE378A2FA5}"/>
+                  <c16:uniqueId val="{00000001-08BF-DE4C-98C3-A0D361776B3F}"/>
                 </c:ext>
               </c:extLst>
             </c:dLbl>
@@ -1753,7 +1753,7 @@
                   <a:lstStyle/>
                   <a:p>
                     <a:r>
-                      <a:rPr sz="1700" b="1">
+                      <a:rPr lang="en-US" sz="1700" b="1">
                         <a:solidFill>
                           <a:srgbClr val="111111"/>
                         </a:solidFill>
@@ -1775,7 +1775,7 @@
                   <c15:showDataLabelsRange val="0"/>
                 </c:ext>
                 <c:ext xmlns:c16="http://schemas.microsoft.com/office/drawing/2014/chart" uri="{C3380CC4-5D6E-409C-BE32-E72D297353CC}">
-                  <c16:uniqueId val="{00000003-C6DF-9047-9AA5-81BE378A2FA5}"/>
+                  <c16:uniqueId val="{00000003-08BF-DE4C-98C3-A0D361776B3F}"/>
                 </c:ext>
               </c:extLst>
             </c:dLbl>
@@ -1787,7 +1787,7 @@
                   <a:lstStyle/>
                   <a:p>
                     <a:r>
-                      <a:rPr sz="1700" b="1">
+                      <a:rPr lang="en-US" sz="1700" b="1">
                         <a:solidFill>
                           <a:srgbClr val="111111"/>
                         </a:solidFill>
@@ -1809,7 +1809,7 @@
                   <c15:showDataLabelsRange val="0"/>
                 </c:ext>
                 <c:ext xmlns:c16="http://schemas.microsoft.com/office/drawing/2014/chart" uri="{C3380CC4-5D6E-409C-BE32-E72D297353CC}">
-                  <c16:uniqueId val="{00000005-C6DF-9047-9AA5-81BE378A2FA5}"/>
+                  <c16:uniqueId val="{00000005-08BF-DE4C-98C3-A0D361776B3F}"/>
                 </c:ext>
               </c:extLst>
             </c:dLbl>
@@ -1821,7 +1821,7 @@
                   <a:lstStyle/>
                   <a:p>
                     <a:r>
-                      <a:rPr sz="1700" b="1">
+                      <a:rPr lang="en-US" sz="1700" b="1">
                         <a:solidFill>
                           <a:srgbClr val="111111"/>
                         </a:solidFill>
@@ -1843,7 +1843,7 @@
                   <c15:showDataLabelsRange val="0"/>
                 </c:ext>
                 <c:ext xmlns:c16="http://schemas.microsoft.com/office/drawing/2014/chart" uri="{C3380CC4-5D6E-409C-BE32-E72D297353CC}">
-                  <c16:uniqueId val="{00000007-C6DF-9047-9AA5-81BE378A2FA5}"/>
+                  <c16:uniqueId val="{00000007-08BF-DE4C-98C3-A0D361776B3F}"/>
                 </c:ext>
               </c:extLst>
             </c:dLbl>
@@ -1855,7 +1855,7 @@
                   <a:lstStyle/>
                   <a:p>
                     <a:r>
-                      <a:rPr sz="1700" b="1">
+                      <a:rPr lang="en-US" sz="1700" b="1">
                         <a:solidFill>
                           <a:srgbClr val="111111"/>
                         </a:solidFill>
@@ -1877,7 +1877,7 @@
                   <c15:showDataLabelsRange val="0"/>
                 </c:ext>
                 <c:ext xmlns:c16="http://schemas.microsoft.com/office/drawing/2014/chart" uri="{C3380CC4-5D6E-409C-BE32-E72D297353CC}">
-                  <c16:uniqueId val="{00000009-C6DF-9047-9AA5-81BE378A2FA5}"/>
+                  <c16:uniqueId val="{00000009-08BF-DE4C-98C3-A0D361776B3F}"/>
                 </c:ext>
               </c:extLst>
             </c:dLbl>
@@ -1961,7 +1961,7 @@
               </c14:invertSolidFillFmt>
             </c:ext>
             <c:ext xmlns:c16="http://schemas.microsoft.com/office/drawing/2014/chart" uri="{C3380CC4-5D6E-409C-BE32-E72D297353CC}">
-              <c16:uniqueId val="{0000000A-C6DF-9047-9AA5-81BE378A2FA5}"/>
+              <c16:uniqueId val="{0000000A-08BF-DE4C-98C3-A0D361776B3F}"/>
             </c:ext>
           </c:extLst>
         </c:ser>
@@ -2178,7 +2178,7 @@
               </c14:invertSolidFillFmt>
             </c:ext>
             <c:ext xmlns:c16="http://schemas.microsoft.com/office/drawing/2014/chart" uri="{C3380CC4-5D6E-409C-BE32-E72D297353CC}">
-              <c16:uniqueId val="{00000000-86D6-F74E-81D0-A1B686030B76}"/>
+              <c16:uniqueId val="{00000000-D51F-1A45-B3E3-1A0A6CEF31C0}"/>
             </c:ext>
           </c:extLst>
         </c:ser>
@@ -2291,7 +2291,7 @@
               </c14:invertSolidFillFmt>
             </c:ext>
             <c:ext xmlns:c16="http://schemas.microsoft.com/office/drawing/2014/chart" uri="{C3380CC4-5D6E-409C-BE32-E72D297353CC}">
-              <c16:uniqueId val="{00000001-86D6-F74E-81D0-A1B686030B76}"/>
+              <c16:uniqueId val="{00000001-D51F-1A45-B3E3-1A0A6CEF31C0}"/>
             </c:ext>
           </c:extLst>
         </c:ser>
@@ -2404,7 +2404,7 @@
               </c14:invertSolidFillFmt>
             </c:ext>
             <c:ext xmlns:c16="http://schemas.microsoft.com/office/drawing/2014/chart" uri="{C3380CC4-5D6E-409C-BE32-E72D297353CC}">
-              <c16:uniqueId val="{00000002-86D6-F74E-81D0-A1B686030B76}"/>
+              <c16:uniqueId val="{00000002-D51F-1A45-B3E3-1A0A6CEF31C0}"/>
             </c:ext>
           </c:extLst>
         </c:ser>
@@ -2561,7 +2561,7 @@
             </c:spPr>
             <c:extLst>
               <c:ext xmlns:c16="http://schemas.microsoft.com/office/drawing/2014/chart" uri="{C3380CC4-5D6E-409C-BE32-E72D297353CC}">
-                <c16:uniqueId val="{00000001-6DC0-874C-9FF9-92DC312BCDE8}"/>
+                <c16:uniqueId val="{00000001-57CA-7A40-B865-EEB7CBDA268E}"/>
               </c:ext>
             </c:extLst>
           </c:dPt>
@@ -2576,7 +2576,7 @@
             </c:spPr>
             <c:extLst>
               <c:ext xmlns:c16="http://schemas.microsoft.com/office/drawing/2014/chart" uri="{C3380CC4-5D6E-409C-BE32-E72D297353CC}">
-                <c16:uniqueId val="{00000003-6DC0-874C-9FF9-92DC312BCDE8}"/>
+                <c16:uniqueId val="{00000003-57CA-7A40-B865-EEB7CBDA268E}"/>
               </c:ext>
             </c:extLst>
           </c:dPt>
@@ -2591,7 +2591,7 @@
             </c:spPr>
             <c:extLst>
               <c:ext xmlns:c16="http://schemas.microsoft.com/office/drawing/2014/chart" uri="{C3380CC4-5D6E-409C-BE32-E72D297353CC}">
-                <c16:uniqueId val="{00000005-6DC0-874C-9FF9-92DC312BCDE8}"/>
+                <c16:uniqueId val="{00000005-57CA-7A40-B865-EEB7CBDA268E}"/>
               </c:ext>
             </c:extLst>
           </c:dPt>
@@ -2606,7 +2606,7 @@
             </c:spPr>
             <c:extLst>
               <c:ext xmlns:c16="http://schemas.microsoft.com/office/drawing/2014/chart" uri="{C3380CC4-5D6E-409C-BE32-E72D297353CC}">
-                <c16:uniqueId val="{00000007-6DC0-874C-9FF9-92DC312BCDE8}"/>
+                <c16:uniqueId val="{00000007-57CA-7A40-B865-EEB7CBDA268E}"/>
               </c:ext>
             </c:extLst>
           </c:dPt>
@@ -2621,7 +2621,7 @@
             </c:spPr>
             <c:extLst>
               <c:ext xmlns:c16="http://schemas.microsoft.com/office/drawing/2014/chart" uri="{C3380CC4-5D6E-409C-BE32-E72D297353CC}">
-                <c16:uniqueId val="{00000009-6DC0-874C-9FF9-92DC312BCDE8}"/>
+                <c16:uniqueId val="{00000009-57CA-7A40-B865-EEB7CBDA268E}"/>
               </c:ext>
             </c:extLst>
           </c:dPt>
@@ -2735,7 +2735,7 @@
               </c14:invertSolidFillFmt>
             </c:ext>
             <c:ext xmlns:c16="http://schemas.microsoft.com/office/drawing/2014/chart" uri="{C3380CC4-5D6E-409C-BE32-E72D297353CC}">
-              <c16:uniqueId val="{0000000A-6DC0-874C-9FF9-92DC312BCDE8}"/>
+              <c16:uniqueId val="{0000000A-57CA-7A40-B865-EEB7CBDA268E}"/>
             </c:ext>
           </c:extLst>
         </c:ser>
@@ -2854,7 +2854,7 @@
     </p:spTree>
     <p:extLst>
       <p:ext uri="{BB962C8B-B14F-4D97-AF65-F5344CB8AC3E}">
-        <p14:creationId xmlns:p14="http://schemas.microsoft.com/office/powerpoint/2010/main" val="155289657"/>
+        <p14:creationId xmlns:p14="http://schemas.microsoft.com/office/powerpoint/2010/main" val="158137740"/>
       </p:ext>
     </p:extLst>
   </p:cSld>
@@ -3004,7 +3004,7 @@
           </a:p>
           <a:p>
             <a:r>
-              <a:t>Speaker: ________</a:t>
+              <a:t>Speaker: Peace</a:t>
             </a:r>
           </a:p>
         </p:txBody>
@@ -3074,12 +3074,14 @@
           <a:lstStyle/>
           <a:p>
             <a:r>
+              <a:rPr dirty="0"/>
               <a:t>[0:50] On the four test months, touched once, checking the riskiest 10% of orders each day would have caught 316 of 876 late orders, 36%. Random checks catch about 88, and the two-feature baseline 294. Flagged orders were late 3.6 times as often as a random order. To be honest about it: the PR-AUC gain over the baseline is real, but at the 10% budget the gain over the baseline is within the noise, because promised days and customer state already carry most of the signal. (README 5.3, 5.4, 6)</a:t>
             </a:r>
           </a:p>
           <a:p>
             <a:r>
-              <a:t>Speaker: ________</a:t>
+              <a:rPr dirty="0"/>
+              <a:t>Speaker: Hasan</a:t>
             </a:r>
           </a:p>
         </p:txBody>
@@ -3149,12 +3151,12 @@
           <a:lstStyle/>
           <a:p>
             <a:r>
-              <a:t>[0:50] On the test set, the strongest drivers are the promised window, distance, customer state, freight and whether the order ships within one state. A promise one standard deviation longer roughly halves the odds of being late. Price, weight, category and purchase time barely matter. Jingyu's error analysis on the last validation fold, before tuning, shows what the model misses: late orders that look ordinary, shorter and more often within one state. All three shortlisted models miss the same two-thirds. Part of that is the budget: on this fold, even a perfect model reviewing 10% of orders would miss 47% of the late ones. The rest points to the data, not the algorithm. A person would have needed the seller's hand-off to the carrier, carrier backlogs, strikes or holidays. (README 4.3, 5.4)</a:t>
+              <a:t>[0:50] On the test set, the strongest drivers are the promised window, distance, customer state, freight and whether the order ships within one state. A promise one standard deviation longer roughly halves the odds of being late. Price, weight, category and purchase time barely matter. My error analysis on the last validation fold, before tuning, shows what the model misses: late orders that look ordinary, shorter and more often within one state. All three shortlisted models miss the same two-thirds, so the limit is the data, not the algorithm. A person would have needed the seller's hand-off to the carrier, carrier backlogs, strikes or holidays. (README 4.3, 5.4)</a:t>
             </a:r>
           </a:p>
           <a:p>
             <a:r>
-              <a:t>Speaker: ________</a:t>
+              <a:t>Speaker: Jingyu</a:t>
             </a:r>
           </a:p>
         </p:txBody>
@@ -3224,12 +3226,12 @@
           <a:lstStyle/>
           <a:p>
             <a:r>
-              <a:t>[0:50] Three assumptions: the promised date is the one the customer saw, ops can review about 10% a day, and the training period's patterns still hold in the test months. The limitations: every model levels off at about 2.0 lift, so 64% of late orders are still missed; the fix is new data such as dispatch scans, carrier data and strike calendars. Scores run about twice too high on the calmer test period, so flag the top 10% rather than using a probability cut-off. At the 10% budget the gain over the baseline is within the noise. And the test window is short and includes the May 2018 truckers' strike. (README 7)</a:t>
+              <a:t>[1:00] Three assumptions, and what happens if they're wrong: the promised date is the one the customer saw, otherwise we'd be measuring the wrong promise; ops can review about 10% a day, which is why we also report 5% and 20%; and the training period's patterns hold in the test months, which the time split tests directly. The limitations: every model levels off at about 2.0 lift, so 64% of late orders are still missed; the fix is new data such as dispatch scans, carrier data and strike calendars. Scores run about twice too high on the calmer test period, so flag the top 10% rather than using a probability cut-off. At the 10% budget the gain over the baseline is within the noise. And the test window is short and includes the May 2018 truckers' strike. (README 7)</a:t>
             </a:r>
           </a:p>
           <a:p>
             <a:r>
-              <a:t>Speaker: ________</a:t>
+              <a:t>Speaker: Jingyu</a:t>
             </a:r>
           </a:p>
         </p:txBody>
@@ -3304,7 +3306,7 @@
           </a:p>
           <a:p>
             <a:r>
-              <a:t>Speaker: ________</a:t>
+              <a:t>Speaker: Jingyu</a:t>
             </a:r>
           </a:p>
         </p:txBody>
@@ -3724,7 +3726,7 @@
           <a:lstStyle/>
           <a:p>
             <a:r>
-              <a:t>Backup: tuning and ensemble comparison (README 5.1, 5.2; ensemble numbers from reports/outputs/5_2_ensemble_comparison.csv).</a:t>
+              <a:t>Backup: tuning and ensemble comparison (README 5.1, 5.2; ensemble numbers from reports/figures/outputs/tasnim_5_2_ensemble_comparison.csv).</a:t>
             </a:r>
           </a:p>
         </p:txBody>
@@ -3799,7 +3801,7 @@
           </a:p>
           <a:p>
             <a:r>
-              <a:t>Speaker: ________</a:t>
+              <a:t>Speaker: Peace</a:t>
             </a:r>
           </a:p>
         </p:txBody>
@@ -3869,7 +3871,7 @@
           <a:lstStyle/>
           <a:p>
             <a:r>
-              <a:t>Backup: monthly test results (reports/outputs/5_3_monthly.csv) and calibration (README 5.4).</a:t>
+              <a:t>Backup: monthly test results (reports/figures/outputs/tasnim_5_3_monthly.csv) and calibration (README 5.4).</a:t>
             </a:r>
           </a:p>
         </p:txBody>
@@ -3944,7 +3946,7 @@
           </a:p>
           <a:p>
             <a:r>
-              <a:t>Speaker: ________</a:t>
+              <a:t>Speaker: Peace</a:t>
             </a:r>
           </a:p>
         </p:txBody>
@@ -4019,7 +4021,7 @@
           </a:p>
           <a:p>
             <a:r>
-              <a:t>Speaker: ________</a:t>
+              <a:t>Speaker: Peace</a:t>
             </a:r>
           </a:p>
         </p:txBody>
@@ -4094,7 +4096,7 @@
           </a:p>
           <a:p>
             <a:r>
-              <a:t>Speaker: ________</a:t>
+              <a:t>Speaker: Mia</a:t>
             </a:r>
           </a:p>
         </p:txBody>
@@ -4169,7 +4171,7 @@
           </a:p>
           <a:p>
             <a:r>
-              <a:t>Speaker: ________</a:t>
+              <a:t>Speaker: Mia</a:t>
             </a:r>
           </a:p>
         </p:txBody>
@@ -4244,7 +4246,7 @@
           </a:p>
           <a:p>
             <a:r>
-              <a:t>Speaker: ________</a:t>
+              <a:t>Speaker: Fidan</a:t>
             </a:r>
           </a:p>
         </p:txBody>
@@ -4314,12 +4316,14 @@
           <a:lstStyle/>
           <a:p>
             <a:r>
-              <a:t>[0:45] Fidan compared seven models from five families plus two baselines, all on the same pipeline and time-series folds. We compare on lift, PR-AUC divided by the fold's late rate, because fold late rates swing from 2.8% to 18.8%. Linear models led, only a little ahead of the two-feature baseline. Tree models started below it: they overfit, with training lift 6 to 12 times their validation lift. The surprise: the EDA pointed to tree models, and they didn't win. We shortlisted logistic regression, random forest and gradient boosting, one per family. (README 4.1, 4.5, 2.7)</a:t>
+              <a:rPr dirty="0"/>
+              <a:t>[0:45] We compared seven models from five families plus two baselines, all on the same pipeline and time-series folds. We compare on lift, PR-AUC divided by the fold's late rate, because fold late rates swing from 2.8% to 18.8%. Linear models led, only a little ahead of the two-feature baseline. Tree models started below it: they overfit, with training lift 6 to 12 times their validation lift. The surprise: the EDA pointed to tree models, and they didn't win. We shortlisted logistic regression, random forest and gradient boosting, one per family. (README 4.1, 4.5, 2.7)</a:t>
             </a:r>
           </a:p>
           <a:p>
             <a:r>
-              <a:t>Speaker: ________</a:t>
+              <a:rPr dirty="0"/>
+              <a:t>Speaker: Fidan</a:t>
             </a:r>
           </a:p>
         </p:txBody>
@@ -4394,7 +4398,7 @@
           </a:p>
           <a:p>
             <a:r>
-              <a:t>Speaker: ________</a:t>
+              <a:t>Speaker: Hasan</a:t>
             </a:r>
           </a:p>
         </p:txBody>
@@ -9405,7 +9409,7 @@
                 </a:solidFill>
                 <a:latin typeface="Calibri"/>
               </a:rPr>
-              <a:t>late orders that look ordinary, shorter than the ones it catches (727 vs 1,011 km) and more often in-state. All 3 models miss 66%, but at a 10% budget even a perfect model misses 47%.</a:t>
+              <a:t>late orders that look ordinary, shorter than the ones it catches (727 vs 1,011 km) and more often in-state. All 3 shortlisted models miss the same 66%.</a:t>
             </a:r>
           </a:p>
         </p:txBody>
@@ -12681,16 +12685,16 @@
                 </a:solidFill>
                 <a:latin typeface="Arial Black"/>
               </a:rPr>
-              <a:t>Thank </a:t>
+              <a:t>Thank you</a:t>
             </a:r>
             <a:r>
-              <a:rPr sz="4400" b="0" i="0">
+              <a:rPr lang="en-US" sz="4400" b="0" i="0" dirty="0">
                 <a:solidFill>
                   <a:srgbClr val="111111"/>
                 </a:solidFill>
                 <a:latin typeface="Arial Black"/>
               </a:rPr>
-              <a:t>you</a:t>
+              <a:t>.</a:t>
             </a:r>
             <a:endParaRPr sz="4400" b="0" i="0" dirty="0">
               <a:solidFill>
@@ -13371,7 +13375,7 @@
 </file>
 
 <file path=ppt/slides/slide15.xml><?xml version="1.0" encoding="utf-8"?>
-<p:sld xmlns:a="http://schemas.openxmlformats.org/drawingml/2006/main" xmlns:r="http://schemas.openxmlformats.org/officeDocument/2006/relationships" xmlns:p="http://schemas.openxmlformats.org/presentationml/2006/main">
+<p:sld xmlns:a="http://schemas.openxmlformats.org/drawingml/2006/main" xmlns:r="http://schemas.openxmlformats.org/officeDocument/2006/relationships" xmlns:p="http://schemas.openxmlformats.org/presentationml/2006/main" show="0">
   <p:cSld>
     <p:bg>
       <p:bgPr>
@@ -13935,7 +13939,7 @@
         <p:spPr>
           <a:xfrm>
             <a:off x="3931920" y="4023360"/>
-            <a:ext cx="10241280" cy="2011680"/>
+            <a:ext cx="10241280" cy="738664"/>
           </a:xfrm>
           <a:prstGeom prst="rect">
             <a:avLst/>
@@ -13954,13 +13958,22 @@
               </a:spcAft>
             </a:pPr>
             <a:r>
-              <a:rPr sz="2400" b="0" i="0">
+              <a:rPr lang="en-US" sz="2400" dirty="0">
                 <a:solidFill>
                   <a:srgbClr val="FFFFFF"/>
                 </a:solidFill>
                 <a:latin typeface="Calibri"/>
               </a:rPr>
-              <a:t>Backup slides for Q&amp;A: full benchmark, leakage controls, validation choices, late rate by state, and test results by month</a:t>
+              <a:t>Includes </a:t>
+            </a:r>
+            <a:r>
+              <a:rPr sz="2400" b="0" i="0" dirty="0">
+                <a:solidFill>
+                  <a:srgbClr val="FFFFFF"/>
+                </a:solidFill>
+                <a:latin typeface="Calibri"/>
+              </a:rPr>
+              <a:t>full benchmark, leakage controls, validation choices, late rate by state, and test results by month</a:t>
             </a:r>
           </a:p>
         </p:txBody>
@@ -13974,7 +13987,7 @@
 </file>
 
 <file path=ppt/slides/slide16.xml><?xml version="1.0" encoding="utf-8"?>
-<p:sld xmlns:a="http://schemas.openxmlformats.org/drawingml/2006/main" xmlns:r="http://schemas.openxmlformats.org/officeDocument/2006/relationships" xmlns:p="http://schemas.openxmlformats.org/presentationml/2006/main">
+<p:sld xmlns:a="http://schemas.openxmlformats.org/drawingml/2006/main" xmlns:r="http://schemas.openxmlformats.org/officeDocument/2006/relationships" xmlns:p="http://schemas.openxmlformats.org/presentationml/2006/main" show="0">
   <p:cSld>
     <p:bg>
       <p:bgPr>
@@ -16979,7 +16992,7 @@
 </file>
 
 <file path=ppt/slides/slide17.xml><?xml version="1.0" encoding="utf-8"?>
-<p:sld xmlns:a="http://schemas.openxmlformats.org/drawingml/2006/main" xmlns:r="http://schemas.openxmlformats.org/officeDocument/2006/relationships" xmlns:p="http://schemas.openxmlformats.org/presentationml/2006/main">
+<p:sld xmlns:a="http://schemas.openxmlformats.org/drawingml/2006/main" xmlns:r="http://schemas.openxmlformats.org/officeDocument/2006/relationships" xmlns:p="http://schemas.openxmlformats.org/presentationml/2006/main" show="0">
   <p:cSld>
     <p:bg>
       <p:bgPr>
@@ -18081,7 +18094,7 @@
 </file>
 
 <file path=ppt/slides/slide18.xml><?xml version="1.0" encoding="utf-8"?>
-<p:sld xmlns:a="http://schemas.openxmlformats.org/drawingml/2006/main" xmlns:r="http://schemas.openxmlformats.org/officeDocument/2006/relationships" xmlns:p="http://schemas.openxmlformats.org/presentationml/2006/main">
+<p:sld xmlns:a="http://schemas.openxmlformats.org/drawingml/2006/main" xmlns:r="http://schemas.openxmlformats.org/officeDocument/2006/relationships" xmlns:p="http://schemas.openxmlformats.org/presentationml/2006/main" show="0">
   <p:cSld>
     <p:bg>
       <p:bgPr>
@@ -18660,7 +18673,7 @@
 </file>
 
 <file path=ppt/slides/slide19.xml><?xml version="1.0" encoding="utf-8"?>
-<p:sld xmlns:a="http://schemas.openxmlformats.org/drawingml/2006/main" xmlns:r="http://schemas.openxmlformats.org/officeDocument/2006/relationships" xmlns:p="http://schemas.openxmlformats.org/presentationml/2006/main">
+<p:sld xmlns:a="http://schemas.openxmlformats.org/drawingml/2006/main" xmlns:r="http://schemas.openxmlformats.org/officeDocument/2006/relationships" xmlns:p="http://schemas.openxmlformats.org/presentationml/2006/main" show="0">
   <p:cSld>
     <p:bg>
       <p:bgPr>
@@ -21564,7 +21577,7 @@
 </file>
 
 <file path=ppt/slides/slide20.xml><?xml version="1.0" encoding="utf-8"?>
-<p:sld xmlns:a="http://schemas.openxmlformats.org/drawingml/2006/main" xmlns:r="http://schemas.openxmlformats.org/officeDocument/2006/relationships" xmlns:p="http://schemas.openxmlformats.org/presentationml/2006/main">
+<p:sld xmlns:a="http://schemas.openxmlformats.org/drawingml/2006/main" xmlns:r="http://schemas.openxmlformats.org/officeDocument/2006/relationships" xmlns:p="http://schemas.openxmlformats.org/presentationml/2006/main" show="0">
   <p:cSld>
     <p:bg>
       <p:bgPr>

</xml_diff>